<commit_message>
feat(paper): move the observed-price cost crossover into Figure 4
- Figure 4 now shows the ammonia-cracking cost history and the Ni-Co
  equal-cost boundary beside the first-rank frequencies and leader cost
  differences; the five-test summary becomes SI Figure S6 and S6-S8 shift
- bind the crossover numbers of the new main-text paragraph and abstract
  clause to the frozen crossover study; update the mass-unit conversion count
- record H49 in the paper review audit

Co-Authored-By: Claude Fable 5.1 <noreply@anthropic.com>
</commit_message>
<xml_diff>
--- a/docs/paper/diagram-sources-2026-09-16/fig4_ranking.pptx
+++ b/docs/paper/diagram-sources-2026-09-16/fig4_ranking.pptx
@@ -8,7 +8,7 @@
     <p:sldId id="256" r:id="rId7"/>
     <p:sldId id="257" r:id="rId9"/>
   </p:sldIdLst>
-  <p:sldSz cx="6408000" cy="7308000" type="screen4x3"/>
+  <p:sldSz cx="6408000" cy="6516000" type="screen4x3"/>
   <p:notesSz cx="6858000" cy="9144000"/>
   <p:defaultTextStyle>
     <a:defPPr>
@@ -3588,7 +3588,7 @@
         <p:spPr>
           <a:xfrm>
             <a:off x="0" y="0"/>
-            <a:ext cx="6408000" cy="7308000"/>
+            <a:ext cx="6408000" cy="6516000"/>
           </a:xfrm>
           <a:prstGeom prst="rect">
             <a:avLst/>
@@ -3640,7 +3640,7 @@
         <p:spPr>
           <a:xfrm>
             <a:off x="0" y="0"/>
-            <a:ext cx="6408000" cy="4716000"/>
+            <a:ext cx="3204000" cy="2160000"/>
           </a:xfrm>
           <a:prstGeom prst="rect">
             <a:avLst/>
@@ -3663,8 +3663,8 @@
         </p:blipFill>
         <p:spPr>
           <a:xfrm>
-            <a:off x="0" y="4752000"/>
-            <a:ext cx="3204000" cy="2556000"/>
+            <a:off x="3204000" y="0"/>
+            <a:ext cx="3204000" cy="2160000"/>
           </a:xfrm>
           <a:prstGeom prst="rect">
             <a:avLst/>
@@ -3687,17 +3687,41 @@
         </p:blipFill>
         <p:spPr>
           <a:xfrm>
-            <a:off x="3204000" y="4752000"/>
-            <a:ext cx="3204000" cy="2556000"/>
+            <a:off x="0" y="2160000"/>
+            <a:ext cx="6408000" cy="2556000"/>
           </a:xfrm>
           <a:prstGeom prst="rect">
             <a:avLst/>
           </a:prstGeom>
         </p:spPr>
       </p:pic>
-      <p:sp>
-        <p:nvSpPr>
-          <p:cNvPr id="6" name="panel-a"/>
+      <p:pic>
+        <p:nvPicPr>
+          <p:cNvPr id="6" name="panel-d-image" descr="fig4_ranking.d.png"/>
+          <p:cNvPicPr>
+            <a:picLocks noChangeAspect="1"/>
+          </p:cNvPicPr>
+          <p:nvPr/>
+        </p:nvPicPr>
+        <p:blipFill>
+          <a:blip r:embed="rId6"/>
+          <a:stretch>
+            <a:fillRect/>
+          </a:stretch>
+        </p:blipFill>
+        <p:spPr>
+          <a:xfrm>
+            <a:off x="0" y="4716000"/>
+            <a:ext cx="6408000" cy="1800000"/>
+          </a:xfrm>
+          <a:prstGeom prst="rect">
+            <a:avLst/>
+          </a:prstGeom>
+        </p:spPr>
+      </p:pic>
+      <p:sp>
+        <p:nvSpPr>
+          <p:cNvPr id="7" name="panel-a"/>
           <p:cNvSpPr txBox="1"/>
           <p:nvPr/>
         </p:nvSpPr>
@@ -3732,13 +3756,13 @@
       </p:sp>
       <p:sp>
         <p:nvSpPr>
-          <p:cNvPr id="7" name="panel-b"/>
+          <p:cNvPr id="8" name="panel-b"/>
           <p:cNvSpPr txBox="1"/>
           <p:nvPr/>
         </p:nvSpPr>
         <p:spPr>
           <a:xfrm>
-            <a:off x="72000" y="4770000"/>
+            <a:off x="3276000" y="18000"/>
             <a:ext cx="252000" cy="180000"/>
           </a:xfrm>
           <a:prstGeom prst="rect">
@@ -3767,13 +3791,13 @@
       </p:sp>
       <p:sp>
         <p:nvSpPr>
-          <p:cNvPr id="8" name="panel-c"/>
+          <p:cNvPr id="9" name="panel-c"/>
           <p:cNvSpPr txBox="1"/>
           <p:nvPr/>
         </p:nvSpPr>
         <p:spPr>
           <a:xfrm>
-            <a:off x="3276000" y="4770000"/>
+            <a:off x="72000" y="2178000"/>
             <a:ext cx="252000" cy="180000"/>
           </a:xfrm>
           <a:prstGeom prst="rect">
@@ -3796,6 +3820,41 @@
                 <a:latin typeface="Arial"/>
               </a:rPr>
               <a:t>(c)</a:t>
+            </a:r>
+          </a:p>
+        </p:txBody>
+      </p:sp>
+      <p:sp>
+        <p:nvSpPr>
+          <p:cNvPr id="10" name="panel-d"/>
+          <p:cNvSpPr txBox="1"/>
+          <p:nvPr/>
+        </p:nvSpPr>
+        <p:spPr>
+          <a:xfrm>
+            <a:off x="72000" y="4734000"/>
+            <a:ext cx="252000" cy="180000"/>
+          </a:xfrm>
+          <a:prstGeom prst="rect">
+            <a:avLst/>
+          </a:prstGeom>
+          <a:noFill/>
+        </p:spPr>
+        <p:txBody>
+          <a:bodyPr wrap="square" lIns="0" rIns="0" tIns="0" bIns="0">
+            <a:spAutoFit/>
+          </a:bodyPr>
+          <a:lstStyle/>
+          <a:p>
+            <a:pPr algn="l"/>
+            <a:r>
+              <a:rPr sz="1000" b="1">
+                <a:solidFill>
+                  <a:srgbClr val="1F2A30"/>
+                </a:solidFill>
+                <a:latin typeface="Arial"/>
+              </a:rPr>
+              <a:t>(d)</a:t>
             </a:r>
           </a:p>
         </p:txBody>
@@ -3827,7 +3886,7 @@
         <p:spPr>
           <a:xfrm>
             <a:off x="0" y="0"/>
-            <a:ext cx="6408000" cy="7308000"/>
+            <a:ext cx="6408000" cy="6516000"/>
           </a:xfrm>
           <a:prstGeom prst="rect">
             <a:avLst/>
@@ -3879,7 +3938,7 @@
         <p:spPr>
           <a:xfrm>
             <a:off x="0" y="0"/>
-            <a:ext cx="6408000" cy="4716000"/>
+            <a:ext cx="3204000" cy="2160000"/>
           </a:xfrm>
           <a:prstGeom prst="rect">
             <a:avLst/>
@@ -3902,8 +3961,8 @@
         </p:blipFill>
         <p:spPr>
           <a:xfrm>
-            <a:off x="0" y="4752000"/>
-            <a:ext cx="3204000" cy="2556000"/>
+            <a:off x="3204000" y="0"/>
+            <a:ext cx="3204000" cy="2160000"/>
           </a:xfrm>
           <a:prstGeom prst="rect">
             <a:avLst/>
@@ -3926,17 +3985,41 @@
         </p:blipFill>
         <p:spPr>
           <a:xfrm>
-            <a:off x="3204000" y="4752000"/>
-            <a:ext cx="3204000" cy="2556000"/>
+            <a:off x="0" y="2160000"/>
+            <a:ext cx="6408000" cy="2556000"/>
           </a:xfrm>
           <a:prstGeom prst="rect">
             <a:avLst/>
           </a:prstGeom>
         </p:spPr>
       </p:pic>
-      <p:sp>
-        <p:nvSpPr>
-          <p:cNvPr id="6" name="panel-a"/>
+      <p:pic>
+        <p:nvPicPr>
+          <p:cNvPr id="6" name="panel-d-image" descr="fig4_ranking.d.ko.png"/>
+          <p:cNvPicPr>
+            <a:picLocks noChangeAspect="1"/>
+          </p:cNvPicPr>
+          <p:nvPr/>
+        </p:nvPicPr>
+        <p:blipFill>
+          <a:blip r:embed="rId6"/>
+          <a:stretch>
+            <a:fillRect/>
+          </a:stretch>
+        </p:blipFill>
+        <p:spPr>
+          <a:xfrm>
+            <a:off x="0" y="4716000"/>
+            <a:ext cx="6408000" cy="1800000"/>
+          </a:xfrm>
+          <a:prstGeom prst="rect">
+            <a:avLst/>
+          </a:prstGeom>
+        </p:spPr>
+      </p:pic>
+      <p:sp>
+        <p:nvSpPr>
+          <p:cNvPr id="7" name="panel-a"/>
           <p:cNvSpPr txBox="1"/>
           <p:nvPr/>
         </p:nvSpPr>
@@ -3971,13 +4054,13 @@
       </p:sp>
       <p:sp>
         <p:nvSpPr>
-          <p:cNvPr id="7" name="panel-b"/>
+          <p:cNvPr id="8" name="panel-b"/>
           <p:cNvSpPr txBox="1"/>
           <p:nvPr/>
         </p:nvSpPr>
         <p:spPr>
           <a:xfrm>
-            <a:off x="72000" y="4770000"/>
+            <a:off x="3276000" y="18000"/>
             <a:ext cx="252000" cy="180000"/>
           </a:xfrm>
           <a:prstGeom prst="rect">
@@ -4006,13 +4089,13 @@
       </p:sp>
       <p:sp>
         <p:nvSpPr>
-          <p:cNvPr id="8" name="panel-c"/>
+          <p:cNvPr id="9" name="panel-c"/>
           <p:cNvSpPr txBox="1"/>
           <p:nvPr/>
         </p:nvSpPr>
         <p:spPr>
           <a:xfrm>
-            <a:off x="3276000" y="4770000"/>
+            <a:off x="72000" y="2178000"/>
             <a:ext cx="252000" cy="180000"/>
           </a:xfrm>
           <a:prstGeom prst="rect">
@@ -4035,6 +4118,41 @@
                 <a:latin typeface="Arial"/>
               </a:rPr>
               <a:t>(c)</a:t>
+            </a:r>
+          </a:p>
+        </p:txBody>
+      </p:sp>
+      <p:sp>
+        <p:nvSpPr>
+          <p:cNvPr id="10" name="panel-d"/>
+          <p:cNvSpPr txBox="1"/>
+          <p:nvPr/>
+        </p:nvSpPr>
+        <p:spPr>
+          <a:xfrm>
+            <a:off x="72000" y="4734000"/>
+            <a:ext cx="252000" cy="180000"/>
+          </a:xfrm>
+          <a:prstGeom prst="rect">
+            <a:avLst/>
+          </a:prstGeom>
+          <a:noFill/>
+        </p:spPr>
+        <p:txBody>
+          <a:bodyPr wrap="square" lIns="0" rIns="0" tIns="0" bIns="0">
+            <a:spAutoFit/>
+          </a:bodyPr>
+          <a:lstStyle/>
+          <a:p>
+            <a:pPr algn="l"/>
+            <a:r>
+              <a:rPr sz="1000" b="1">
+                <a:solidFill>
+                  <a:srgbClr val="1F2A30"/>
+                </a:solidFill>
+                <a:latin typeface="Arial"/>
+              </a:rPr>
+              <a:t>(d)</a:t>
             </a:r>
           </a:p>
         </p:txBody>

</xml_diff>